<commit_message>
Updated README, added Report, updated Presentation.
</commit_message>
<xml_diff>
--- a/Presentation.pptx
+++ b/Presentation.pptx
@@ -14,6 +14,7 @@
     <p:sldId id="262" r:id="rId8"/>
     <p:sldId id="263" r:id="rId9"/>
     <p:sldId id="264" r:id="rId10"/>
+    <p:sldId id="265" r:id="rId11"/>
   </p:sldIdLst>
   <p:sldSz cx="12192000" cy="6858000"/>
   <p:notesSz cx="6858000" cy="9144000"/>
@@ -4774,7 +4775,7 @@
           <a:p>
             <a:fld id="{48A87A34-81AB-432B-8DAE-1953F412C126}" type="datetimeFigureOut">
               <a:rPr lang="en-US" dirty="0"/>
-              <a:t>4/19/26</a:t>
+              <a:t>4/20/26</a:t>
             </a:fld>
             <a:endParaRPr lang="en-US" dirty="0"/>
           </a:p>
@@ -5036,7 +5037,7 @@
           <a:p>
             <a:fld id="{48A87A34-81AB-432B-8DAE-1953F412C126}" type="datetimeFigureOut">
               <a:rPr lang="en-US" dirty="0"/>
-              <a:t>4/19/26</a:t>
+              <a:t>4/20/26</a:t>
             </a:fld>
             <a:endParaRPr lang="en-US" dirty="0"/>
           </a:p>
@@ -5227,7 +5228,7 @@
           <a:p>
             <a:fld id="{48A87A34-81AB-432B-8DAE-1953F412C126}" type="datetimeFigureOut">
               <a:rPr lang="en-US" dirty="0"/>
-              <a:t>4/19/26</a:t>
+              <a:t>4/20/26</a:t>
             </a:fld>
             <a:endParaRPr lang="en-US" dirty="0"/>
           </a:p>
@@ -5485,7 +5486,7 @@
           <a:p>
             <a:fld id="{48A87A34-81AB-432B-8DAE-1953F412C126}" type="datetimeFigureOut">
               <a:rPr lang="en-US" dirty="0"/>
-              <a:t>4/19/26</a:t>
+              <a:t>4/20/26</a:t>
             </a:fld>
             <a:endParaRPr lang="en-US" dirty="0"/>
           </a:p>
@@ -5914,7 +5915,7 @@
           <a:p>
             <a:fld id="{48A87A34-81AB-432B-8DAE-1953F412C126}" type="datetimeFigureOut">
               <a:rPr lang="en-US" dirty="0"/>
-              <a:t>4/19/26</a:t>
+              <a:t>4/20/26</a:t>
             </a:fld>
             <a:endParaRPr lang="en-US" dirty="0"/>
           </a:p>
@@ -6455,7 +6456,7 @@
           <a:p>
             <a:fld id="{48A87A34-81AB-432B-8DAE-1953F412C126}" type="datetimeFigureOut">
               <a:rPr lang="en-US" dirty="0"/>
-              <a:t>4/19/26</a:t>
+              <a:t>4/20/26</a:t>
             </a:fld>
             <a:endParaRPr lang="en-US" dirty="0"/>
           </a:p>
@@ -7170,7 +7171,7 @@
           <a:p>
             <a:fld id="{48A87A34-81AB-432B-8DAE-1953F412C126}" type="datetimeFigureOut">
               <a:rPr lang="en-US" dirty="0"/>
-              <a:t>4/19/26</a:t>
+              <a:t>4/20/26</a:t>
             </a:fld>
             <a:endParaRPr lang="en-US" dirty="0"/>
           </a:p>
@@ -7335,7 +7336,7 @@
           <a:p>
             <a:fld id="{48A87A34-81AB-432B-8DAE-1953F412C126}" type="datetimeFigureOut">
               <a:rPr lang="en-US" dirty="0"/>
-              <a:t>4/19/26</a:t>
+              <a:t>4/20/26</a:t>
             </a:fld>
             <a:endParaRPr lang="en-US" dirty="0"/>
           </a:p>
@@ -7510,7 +7511,7 @@
           <a:p>
             <a:fld id="{48A87A34-81AB-432B-8DAE-1953F412C126}" type="datetimeFigureOut">
               <a:rPr lang="en-US" dirty="0"/>
-              <a:t>4/19/26</a:t>
+              <a:t>4/20/26</a:t>
             </a:fld>
             <a:endParaRPr lang="en-US" dirty="0"/>
           </a:p>
@@ -7675,7 +7676,7 @@
           <a:p>
             <a:fld id="{48A87A34-81AB-432B-8DAE-1953F412C126}" type="datetimeFigureOut">
               <a:rPr lang="en-US" dirty="0"/>
-              <a:t>4/19/26</a:t>
+              <a:t>4/20/26</a:t>
             </a:fld>
             <a:endParaRPr lang="en-US" dirty="0"/>
           </a:p>
@@ -7920,7 +7921,7 @@
           <a:p>
             <a:fld id="{48A87A34-81AB-432B-8DAE-1953F412C126}" type="datetimeFigureOut">
               <a:rPr lang="en-US" dirty="0"/>
-              <a:t>4/19/26</a:t>
+              <a:t>4/20/26</a:t>
             </a:fld>
             <a:endParaRPr lang="en-US" dirty="0"/>
           </a:p>
@@ -8147,7 +8148,7 @@
           <a:p>
             <a:fld id="{48A87A34-81AB-432B-8DAE-1953F412C126}" type="datetimeFigureOut">
               <a:rPr lang="en-US" dirty="0"/>
-              <a:t>4/19/26</a:t>
+              <a:t>4/20/26</a:t>
             </a:fld>
             <a:endParaRPr lang="en-US" dirty="0"/>
           </a:p>
@@ -8523,7 +8524,7 @@
           <a:p>
             <a:fld id="{48A87A34-81AB-432B-8DAE-1953F412C126}" type="datetimeFigureOut">
               <a:rPr lang="en-US" dirty="0"/>
-              <a:t>4/19/26</a:t>
+              <a:t>4/20/26</a:t>
             </a:fld>
             <a:endParaRPr lang="en-US" dirty="0"/>
           </a:p>
@@ -8636,7 +8637,7 @@
           <a:p>
             <a:fld id="{48A87A34-81AB-432B-8DAE-1953F412C126}" type="datetimeFigureOut">
               <a:rPr lang="en-US" dirty="0"/>
-              <a:t>4/19/26</a:t>
+              <a:t>4/20/26</a:t>
             </a:fld>
             <a:endParaRPr lang="en-US" dirty="0"/>
           </a:p>
@@ -8726,7 +8727,7 @@
           <a:p>
             <a:fld id="{48A87A34-81AB-432B-8DAE-1953F412C126}" type="datetimeFigureOut">
               <a:rPr lang="en-US" dirty="0"/>
-              <a:t>4/19/26</a:t>
+              <a:t>4/20/26</a:t>
             </a:fld>
             <a:endParaRPr lang="en-US" dirty="0"/>
           </a:p>
@@ -8970,7 +8971,7 @@
           <a:p>
             <a:fld id="{48A87A34-81AB-432B-8DAE-1953F412C126}" type="datetimeFigureOut">
               <a:rPr lang="en-US" dirty="0"/>
-              <a:t>4/19/26</a:t>
+              <a:t>4/20/26</a:t>
             </a:fld>
             <a:endParaRPr lang="en-US" dirty="0"/>
           </a:p>
@@ -9245,7 +9246,7 @@
           <a:p>
             <a:fld id="{48A87A34-81AB-432B-8DAE-1953F412C126}" type="datetimeFigureOut">
               <a:rPr lang="en-US" dirty="0"/>
-              <a:t>4/19/26</a:t>
+              <a:t>4/20/26</a:t>
             </a:fld>
             <a:endParaRPr lang="en-US" dirty="0"/>
           </a:p>
@@ -12577,7 +12578,7 @@
             <a:fld id="{48A87A34-81AB-432B-8DAE-1953F412C126}" type="datetimeFigureOut">
               <a:rPr lang="en-US" dirty="0"/>
               <a:pPr/>
-              <a:t>4/19/26</a:t>
+              <a:t>4/20/26</a:t>
             </a:fld>
             <a:endParaRPr lang="en-US" dirty="0"/>
           </a:p>
@@ -13069,6 +13070,100 @@
 </p:sld>
 </file>
 
+<file path=ppt/slides/slide10.xml><?xml version="1.0" encoding="utf-8"?>
+<p:sld xmlns:a="http://schemas.openxmlformats.org/drawingml/2006/main" xmlns:r="http://schemas.openxmlformats.org/officeDocument/2006/relationships" xmlns:p="http://schemas.openxmlformats.org/presentationml/2006/main">
+  <p:cSld>
+    <p:spTree>
+      <p:nvGrpSpPr>
+        <p:cNvPr id="1" name=""/>
+        <p:cNvGrpSpPr/>
+        <p:nvPr/>
+      </p:nvGrpSpPr>
+      <p:grpSpPr>
+        <a:xfrm>
+          <a:off x="0" y="0"/>
+          <a:ext cx="0" cy="0"/>
+          <a:chOff x="0" y="0"/>
+          <a:chExt cx="0" cy="0"/>
+        </a:xfrm>
+      </p:grpSpPr>
+      <p:sp>
+        <p:nvSpPr>
+          <p:cNvPr id="2" name="Title 1">
+            <a:extLst>
+              <a:ext uri="{FF2B5EF4-FFF2-40B4-BE49-F238E27FC236}">
+                <a16:creationId xmlns:a16="http://schemas.microsoft.com/office/drawing/2014/main" id="{AB9287DC-9AC3-92CB-50F2-C9DA5A93D2DF}"/>
+              </a:ext>
+            </a:extLst>
+          </p:cNvPr>
+          <p:cNvSpPr>
+            <a:spLocks noGrp="1"/>
+          </p:cNvSpPr>
+          <p:nvPr>
+            <p:ph type="title"/>
+          </p:nvPr>
+        </p:nvSpPr>
+        <p:spPr/>
+        <p:txBody>
+          <a:bodyPr/>
+          <a:lstStyle/>
+          <a:p>
+            <a:r>
+              <a:rPr lang="en-US" dirty="0"/>
+              <a:t>Git Repo</a:t>
+            </a:r>
+          </a:p>
+        </p:txBody>
+      </p:sp>
+      <p:sp>
+        <p:nvSpPr>
+          <p:cNvPr id="3" name="Content Placeholder 2">
+            <a:extLst>
+              <a:ext uri="{FF2B5EF4-FFF2-40B4-BE49-F238E27FC236}">
+                <a16:creationId xmlns:a16="http://schemas.microsoft.com/office/drawing/2014/main" id="{E936C02B-6003-3F0E-A23F-B038DE5314AD}"/>
+              </a:ext>
+            </a:extLst>
+          </p:cNvPr>
+          <p:cNvSpPr>
+            <a:spLocks noGrp="1"/>
+          </p:cNvSpPr>
+          <p:nvPr>
+            <p:ph idx="1"/>
+          </p:nvPr>
+        </p:nvSpPr>
+        <p:spPr/>
+        <p:txBody>
+          <a:bodyPr/>
+          <a:lstStyle/>
+          <a:p>
+            <a:r>
+              <a:rPr lang="en-US" dirty="0"/>
+              <a:t>https://</a:t>
+            </a:r>
+            <a:r>
+              <a:rPr lang="en-US" dirty="0" err="1"/>
+              <a:t>github.com</a:t>
+            </a:r>
+            <a:r>
+              <a:rPr lang="en-US" dirty="0"/>
+              <a:t>/rharding8/PersonalOSv2</a:t>
+            </a:r>
+          </a:p>
+        </p:txBody>
+      </p:sp>
+    </p:spTree>
+    <p:extLst>
+      <p:ext uri="{BB962C8B-B14F-4D97-AF65-F5344CB8AC3E}">
+        <p14:creationId xmlns:p14="http://schemas.microsoft.com/office/powerpoint/2010/main" val="1598009005"/>
+      </p:ext>
+    </p:extLst>
+  </p:cSld>
+  <p:clrMapOvr>
+    <a:masterClrMapping/>
+  </p:clrMapOvr>
+</p:sld>
+</file>
+
 <file path=ppt/slides/slide2.xml><?xml version="1.0" encoding="utf-8"?>
 <p:sld xmlns:a="http://schemas.openxmlformats.org/drawingml/2006/main" xmlns:r="http://schemas.openxmlformats.org/officeDocument/2006/relationships" xmlns:p="http://schemas.openxmlformats.org/presentationml/2006/main">
   <p:cSld>
@@ -13138,8 +13233,8 @@
         </p:blipFill>
         <p:spPr>
           <a:xfrm>
-            <a:off x="5822156" y="1737519"/>
-            <a:ext cx="4559300" cy="2908300"/>
+            <a:off x="5002742" y="1377324"/>
+            <a:ext cx="6432766" cy="4103352"/>
           </a:xfrm>
           <a:prstGeom prst="rect">
             <a:avLst/>
@@ -13305,8 +13400,8 @@
         </p:blipFill>
         <p:spPr>
           <a:xfrm>
-            <a:off x="5828506" y="1858169"/>
-            <a:ext cx="4546600" cy="2667000"/>
+            <a:off x="5002742" y="1481977"/>
+            <a:ext cx="6485768" cy="3804501"/>
           </a:xfrm>
           <a:prstGeom prst="rect">
             <a:avLst/>
@@ -13362,7 +13457,7 @@
             </a:pPr>
             <a:r>
               <a:rPr lang="en-US" dirty="0"/>
-              <a:t>Simple Bitmapped Memory</a:t>
+              <a:t>Simple Bitmapped Memory with Heap</a:t>
             </a:r>
           </a:p>
           <a:p>
@@ -13633,7 +13728,7 @@
         <p:spPr>
           <a:xfrm>
             <a:off x="293114" y="2097088"/>
-            <a:ext cx="4878387" cy="2113420"/>
+            <a:ext cx="5356794" cy="2320676"/>
           </a:xfrm>
           <a:prstGeom prst="rect">
             <a:avLst/>
@@ -13664,7 +13759,7 @@
         </p:blipFill>
         <p:spPr>
           <a:xfrm>
-            <a:off x="5357152" y="1082929"/>
+            <a:off x="5852911" y="1082929"/>
             <a:ext cx="5690259" cy="5156553"/>
           </a:xfrm>
           <a:prstGeom prst="rect">
@@ -13961,13 +14056,13 @@
           <a:p>
             <a:r>
               <a:rPr lang="en-US" dirty="0"/>
-              <a:t>Finish Syntax/Error Enforcement and fix bugs</a:t>
+              <a:t>Finish Syntax/Error Enforcement</a:t>
             </a:r>
           </a:p>
           <a:p>
             <a:r>
               <a:rPr lang="en-US" dirty="0"/>
-              <a:t>Use full memory map + memory protection</a:t>
+              <a:t>Memory protection</a:t>
             </a:r>
           </a:p>
           <a:p>

</xml_diff>